<commit_message>
changes to powerpoint 1
</commit_message>
<xml_diff>
--- a/Prototype 1/Design_Document_Prototype1.pptx
+++ b/Prototype 1/Design_Document_Prototype1.pptx
@@ -5,7 +5,7 @@
     <p:sldMasterId id="2147483648" r:id="rId1"/>
   </p:sldMasterIdLst>
   <p:notesMasterIdLst>
-    <p:notesMasterId r:id="rId10"/>
+    <p:notesMasterId r:id="rId13"/>
   </p:notesMasterIdLst>
   <p:sldIdLst>
     <p:sldId id="256" r:id="rId2"/>
@@ -16,6 +16,9 @@
     <p:sldId id="261" r:id="rId7"/>
     <p:sldId id="262" r:id="rId8"/>
     <p:sldId id="263" r:id="rId9"/>
+    <p:sldId id="264" r:id="rId10"/>
+    <p:sldId id="265" r:id="rId11"/>
+    <p:sldId id="266" r:id="rId12"/>
   </p:sldIdLst>
   <p:sldSz cx="9144000" cy="6858000" type="screen4x3"/>
   <p:notesSz cx="6858000" cy="9144000"/>
@@ -215,7 +218,7 @@
           <a:p>
             <a:fld id="{9B6B4484-2918-432D-AEA9-C72E81B09694}" type="datetimeFigureOut">
               <a:rPr lang="en-GB" smtClean="0"/>
-              <a:t>02/05/2026</a:t>
+              <a:t>08/05/2026</a:t>
             </a:fld>
             <a:endParaRPr lang="en-GB"/>
           </a:p>
@@ -662,7 +665,7 @@
           <a:p>
             <a:fld id="{5BCAD085-E8A6-8845-BD4E-CB4CCA059FC4}" type="datetimeFigureOut">
               <a:rPr lang="en-US" smtClean="0"/>
-              <a:t>5/2/2026</a:t>
+              <a:t>5/8/2026</a:t>
             </a:fld>
             <a:endParaRPr lang="en-US"/>
           </a:p>
@@ -830,7 +833,7 @@
           <a:p>
             <a:fld id="{5BCAD085-E8A6-8845-BD4E-CB4CCA059FC4}" type="datetimeFigureOut">
               <a:rPr lang="en-US" smtClean="0"/>
-              <a:t>5/2/2026</a:t>
+              <a:t>5/8/2026</a:t>
             </a:fld>
             <a:endParaRPr lang="en-US"/>
           </a:p>
@@ -1008,7 +1011,7 @@
           <a:p>
             <a:fld id="{5BCAD085-E8A6-8845-BD4E-CB4CCA059FC4}" type="datetimeFigureOut">
               <a:rPr lang="en-US" smtClean="0"/>
-              <a:t>5/2/2026</a:t>
+              <a:t>5/8/2026</a:t>
             </a:fld>
             <a:endParaRPr lang="en-US"/>
           </a:p>
@@ -1176,7 +1179,7 @@
           <a:p>
             <a:fld id="{5BCAD085-E8A6-8845-BD4E-CB4CCA059FC4}" type="datetimeFigureOut">
               <a:rPr lang="en-US" smtClean="0"/>
-              <a:t>5/2/2026</a:t>
+              <a:t>5/8/2026</a:t>
             </a:fld>
             <a:endParaRPr lang="en-US"/>
           </a:p>
@@ -1421,7 +1424,7 @@
           <a:p>
             <a:fld id="{5BCAD085-E8A6-8845-BD4E-CB4CCA059FC4}" type="datetimeFigureOut">
               <a:rPr lang="en-US" smtClean="0"/>
-              <a:t>5/2/2026</a:t>
+              <a:t>5/8/2026</a:t>
             </a:fld>
             <a:endParaRPr lang="en-US"/>
           </a:p>
@@ -1706,7 +1709,7 @@
           <a:p>
             <a:fld id="{5BCAD085-E8A6-8845-BD4E-CB4CCA059FC4}" type="datetimeFigureOut">
               <a:rPr lang="en-US" smtClean="0"/>
-              <a:t>5/2/2026</a:t>
+              <a:t>5/8/2026</a:t>
             </a:fld>
             <a:endParaRPr lang="en-US"/>
           </a:p>
@@ -2125,7 +2128,7 @@
           <a:p>
             <a:fld id="{5BCAD085-E8A6-8845-BD4E-CB4CCA059FC4}" type="datetimeFigureOut">
               <a:rPr lang="en-US" smtClean="0"/>
-              <a:t>5/2/2026</a:t>
+              <a:t>5/8/2026</a:t>
             </a:fld>
             <a:endParaRPr lang="en-US"/>
           </a:p>
@@ -2242,7 +2245,7 @@
           <a:p>
             <a:fld id="{5BCAD085-E8A6-8845-BD4E-CB4CCA059FC4}" type="datetimeFigureOut">
               <a:rPr lang="en-US" smtClean="0"/>
-              <a:t>5/2/2026</a:t>
+              <a:t>5/8/2026</a:t>
             </a:fld>
             <a:endParaRPr lang="en-US"/>
           </a:p>
@@ -2337,7 +2340,7 @@
           <a:p>
             <a:fld id="{5BCAD085-E8A6-8845-BD4E-CB4CCA059FC4}" type="datetimeFigureOut">
               <a:rPr lang="en-US" smtClean="0"/>
-              <a:t>5/2/2026</a:t>
+              <a:t>5/8/2026</a:t>
             </a:fld>
             <a:endParaRPr lang="en-US"/>
           </a:p>
@@ -2612,7 +2615,7 @@
           <a:p>
             <a:fld id="{5BCAD085-E8A6-8845-BD4E-CB4CCA059FC4}" type="datetimeFigureOut">
               <a:rPr lang="en-US" smtClean="0"/>
-              <a:t>5/2/2026</a:t>
+              <a:t>5/8/2026</a:t>
             </a:fld>
             <a:endParaRPr lang="en-US"/>
           </a:p>
@@ -2864,7 +2867,7 @@
           <a:p>
             <a:fld id="{5BCAD085-E8A6-8845-BD4E-CB4CCA059FC4}" type="datetimeFigureOut">
               <a:rPr lang="en-US" smtClean="0"/>
-              <a:t>5/2/2026</a:t>
+              <a:t>5/8/2026</a:t>
             </a:fld>
             <a:endParaRPr lang="en-US"/>
           </a:p>
@@ -3075,7 +3078,7 @@
           <a:p>
             <a:fld id="{5BCAD085-E8A6-8845-BD4E-CB4CCA059FC4}" type="datetimeFigureOut">
               <a:rPr lang="en-US" smtClean="0"/>
-              <a:t>5/2/2026</a:t>
+              <a:t>5/8/2026</a:t>
             </a:fld>
             <a:endParaRPr lang="en-US"/>
           </a:p>
@@ -3826,6 +3829,959 @@
 </p:sld>
 </file>
 
+<file path=ppt/slides/slide10.xml><?xml version="1.0" encoding="utf-8"?>
+<p:sld xmlns:a="http://schemas.openxmlformats.org/drawingml/2006/main" xmlns:r="http://schemas.openxmlformats.org/officeDocument/2006/relationships" xmlns:p="http://schemas.openxmlformats.org/presentationml/2006/main">
+  <p:cSld>
+    <p:bg>
+      <p:bgPr>
+        <a:solidFill>
+          <a:schemeClr val="bg1"/>
+        </a:solidFill>
+        <a:effectLst/>
+      </p:bgPr>
+    </p:bg>
+    <p:spTree>
+      <p:nvGrpSpPr>
+        <p:cNvPr id="1" name="">
+          <a:extLst>
+            <a:ext uri="{FF2B5EF4-FFF2-40B4-BE49-F238E27FC236}">
+              <a16:creationId xmlns:a16="http://schemas.microsoft.com/office/drawing/2014/main" id="{74A4E760-1D7A-A187-9ACB-D7ED67E91122}"/>
+            </a:ext>
+          </a:extLst>
+        </p:cNvPr>
+        <p:cNvGrpSpPr/>
+        <p:nvPr/>
+      </p:nvGrpSpPr>
+      <p:grpSpPr>
+        <a:xfrm>
+          <a:off x="0" y="0"/>
+          <a:ext cx="0" cy="0"/>
+          <a:chOff x="0" y="0"/>
+          <a:chExt cx="0" cy="0"/>
+        </a:xfrm>
+      </p:grpSpPr>
+      <p:sp>
+        <p:nvSpPr>
+          <p:cNvPr id="33" name="Rectangle 32">
+            <a:extLst>
+              <a:ext uri="{FF2B5EF4-FFF2-40B4-BE49-F238E27FC236}">
+                <a16:creationId xmlns:a16="http://schemas.microsoft.com/office/drawing/2014/main" id="{B34F5AD2-EDBD-4BBD-A55C-EAFFD0C7097A}"/>
+              </a:ext>
+              <a:ext uri="{C183D7F6-B498-43B3-948B-1728B52AA6E4}">
+                <adec:decorative xmlns:adec="http://schemas.microsoft.com/office/drawing/2017/decorative" val="1"/>
+              </a:ext>
+            </a:extLst>
+          </p:cNvPr>
+          <p:cNvSpPr>
+            <a:spLocks noGrp="1" noRot="1" noChangeAspect="1" noMove="1" noResize="1" noEditPoints="1" noAdjustHandles="1" noChangeArrowheads="1" noChangeShapeType="1" noTextEdit="1"/>
+          </p:cNvSpPr>
+          <p:nvPr>
+            <p:extLst>
+              <p:ext uri="{386F3935-93C4-4BCD-93E2-E3B085C9AB24}">
+                <p16:designElem xmlns:p16="http://schemas.microsoft.com/office/powerpoint/2015/main" val="1"/>
+              </p:ext>
+            </p:extLst>
+          </p:nvPr>
+        </p:nvSpPr>
+        <p:spPr>
+          <a:xfrm>
+            <a:off x="2805287" y="0"/>
+            <a:ext cx="6338705" cy="6858001"/>
+          </a:xfrm>
+          <a:prstGeom prst="rect">
+            <a:avLst/>
+          </a:prstGeom>
+          <a:solidFill>
+            <a:schemeClr val="bg1">
+              <a:lumMod val="95000"/>
+            </a:schemeClr>
+          </a:solidFill>
+          <a:ln>
+            <a:noFill/>
+          </a:ln>
+        </p:spPr>
+        <p:style>
+          <a:lnRef idx="2">
+            <a:schemeClr val="accent1">
+              <a:shade val="50000"/>
+            </a:schemeClr>
+          </a:lnRef>
+          <a:fillRef idx="1">
+            <a:schemeClr val="accent1"/>
+          </a:fillRef>
+          <a:effectRef idx="0">
+            <a:schemeClr val="accent1"/>
+          </a:effectRef>
+          <a:fontRef idx="minor">
+            <a:schemeClr val="lt1"/>
+          </a:fontRef>
+        </p:style>
+        <p:txBody>
+          <a:bodyPr rtlCol="0" anchor="ctr"/>
+          <a:lstStyle/>
+          <a:p>
+            <a:pPr algn="ctr"/>
+            <a:endParaRPr lang="en-US"/>
+          </a:p>
+        </p:txBody>
+      </p:sp>
+      <p:sp>
+        <p:nvSpPr>
+          <p:cNvPr id="35" name="Rectangle 34">
+            <a:extLst>
+              <a:ext uri="{FF2B5EF4-FFF2-40B4-BE49-F238E27FC236}">
+                <a16:creationId xmlns:a16="http://schemas.microsoft.com/office/drawing/2014/main" id="{C3896A03-3945-419A-B66B-4EE266EDD152}"/>
+              </a:ext>
+              <a:ext uri="{C183D7F6-B498-43B3-948B-1728B52AA6E4}">
+                <adec:decorative xmlns:adec="http://schemas.microsoft.com/office/drawing/2017/decorative" val="1"/>
+              </a:ext>
+            </a:extLst>
+          </p:cNvPr>
+          <p:cNvSpPr>
+            <a:spLocks noGrp="1" noRot="1" noChangeAspect="1" noMove="1" noResize="1" noEditPoints="1" noAdjustHandles="1" noChangeArrowheads="1" noChangeShapeType="1" noTextEdit="1"/>
+          </p:cNvSpPr>
+          <p:nvPr>
+            <p:extLst>
+              <p:ext uri="{386F3935-93C4-4BCD-93E2-E3B085C9AB24}">
+                <p16:designElem xmlns:p16="http://schemas.microsoft.com/office/powerpoint/2015/main" val="1"/>
+              </p:ext>
+            </p:extLst>
+          </p:nvPr>
+        </p:nvSpPr>
+        <p:spPr>
+          <a:xfrm>
+            <a:off x="7" y="0"/>
+            <a:ext cx="2808883" cy="6858001"/>
+          </a:xfrm>
+          <a:prstGeom prst="rect">
+            <a:avLst/>
+          </a:prstGeom>
+          <a:solidFill>
+            <a:schemeClr val="tx1">
+              <a:lumMod val="85000"/>
+              <a:lumOff val="15000"/>
+            </a:schemeClr>
+          </a:solidFill>
+          <a:ln>
+            <a:noFill/>
+          </a:ln>
+        </p:spPr>
+        <p:style>
+          <a:lnRef idx="2">
+            <a:schemeClr val="accent1">
+              <a:shade val="50000"/>
+            </a:schemeClr>
+          </a:lnRef>
+          <a:fillRef idx="1">
+            <a:schemeClr val="accent1"/>
+          </a:fillRef>
+          <a:effectRef idx="0">
+            <a:schemeClr val="accent1"/>
+          </a:effectRef>
+          <a:fontRef idx="minor">
+            <a:schemeClr val="lt1"/>
+          </a:fontRef>
+        </p:style>
+        <p:txBody>
+          <a:bodyPr rtlCol="0" anchor="ctr"/>
+          <a:lstStyle/>
+          <a:p>
+            <a:pPr algn="ctr"/>
+            <a:endParaRPr lang="en-US"/>
+          </a:p>
+        </p:txBody>
+      </p:sp>
+      <p:sp>
+        <p:nvSpPr>
+          <p:cNvPr id="2" name="Title 1">
+            <a:extLst>
+              <a:ext uri="{FF2B5EF4-FFF2-40B4-BE49-F238E27FC236}">
+                <a16:creationId xmlns:a16="http://schemas.microsoft.com/office/drawing/2014/main" id="{B1CEE96A-F547-460F-9597-24B5D4271B13}"/>
+              </a:ext>
+            </a:extLst>
+          </p:cNvPr>
+          <p:cNvSpPr>
+            <a:spLocks noGrp="1"/>
+          </p:cNvSpPr>
+          <p:nvPr>
+            <p:ph type="title"/>
+          </p:nvPr>
+        </p:nvSpPr>
+        <p:spPr>
+          <a:xfrm>
+            <a:off x="867639" y="637762"/>
+            <a:ext cx="1643086" cy="5576770"/>
+          </a:xfrm>
+        </p:spPr>
+        <p:txBody>
+          <a:bodyPr anchor="t">
+            <a:normAutofit/>
+          </a:bodyPr>
+          <a:lstStyle/>
+          <a:p>
+            <a:pPr algn="l"/>
+            <a:r>
+              <a:rPr lang="en-GB" sz="2600">
+                <a:solidFill>
+                  <a:schemeClr val="bg1"/>
+                </a:solidFill>
+              </a:rPr>
+              <a:t>Post Processing Effects</a:t>
+            </a:r>
+          </a:p>
+        </p:txBody>
+      </p:sp>
+      <p:sp>
+        <p:nvSpPr>
+          <p:cNvPr id="37" name="Rectangle 36">
+            <a:extLst>
+              <a:ext uri="{FF2B5EF4-FFF2-40B4-BE49-F238E27FC236}">
+                <a16:creationId xmlns:a16="http://schemas.microsoft.com/office/drawing/2014/main" id="{B8EAE243-3A9F-4A46-B0D9-04C723A8A1BD}"/>
+              </a:ext>
+              <a:ext uri="{C183D7F6-B498-43B3-948B-1728B52AA6E4}">
+                <adec:decorative xmlns:adec="http://schemas.microsoft.com/office/drawing/2017/decorative" val="1"/>
+              </a:ext>
+            </a:extLst>
+          </p:cNvPr>
+          <p:cNvSpPr>
+            <a:spLocks noGrp="1" noRot="1" noChangeAspect="1" noMove="1" noResize="1" noEditPoints="1" noAdjustHandles="1" noChangeArrowheads="1" noChangeShapeType="1" noTextEdit="1"/>
+          </p:cNvSpPr>
+          <p:nvPr>
+            <p:extLst>
+              <p:ext uri="{386F3935-93C4-4BCD-93E2-E3B085C9AB24}">
+                <p16:designElem xmlns:p16="http://schemas.microsoft.com/office/powerpoint/2015/main" val="1"/>
+              </p:ext>
+            </p:extLst>
+          </p:nvPr>
+        </p:nvSpPr>
+        <p:spPr>
+          <a:xfrm>
+            <a:off x="3491049" y="643465"/>
+            <a:ext cx="342900" cy="45720"/>
+          </a:xfrm>
+          <a:prstGeom prst="rect">
+            <a:avLst/>
+          </a:prstGeom>
+          <a:solidFill>
+            <a:schemeClr val="tx1"/>
+          </a:solidFill>
+          <a:ln>
+            <a:noFill/>
+          </a:ln>
+        </p:spPr>
+        <p:style>
+          <a:lnRef idx="2">
+            <a:schemeClr val="accent1">
+              <a:shade val="50000"/>
+            </a:schemeClr>
+          </a:lnRef>
+          <a:fillRef idx="1">
+            <a:schemeClr val="accent1"/>
+          </a:fillRef>
+          <a:effectRef idx="0">
+            <a:schemeClr val="accent1"/>
+          </a:effectRef>
+          <a:fontRef idx="minor">
+            <a:schemeClr val="lt1"/>
+          </a:fontRef>
+        </p:style>
+        <p:txBody>
+          <a:bodyPr rtlCol="0" anchor="ctr"/>
+          <a:lstStyle/>
+          <a:p>
+            <a:pPr algn="ctr"/>
+            <a:endParaRPr lang="en-US"/>
+          </a:p>
+        </p:txBody>
+      </p:sp>
+      <p:sp>
+        <p:nvSpPr>
+          <p:cNvPr id="3" name="Content Placeholder 2">
+            <a:extLst>
+              <a:ext uri="{FF2B5EF4-FFF2-40B4-BE49-F238E27FC236}">
+                <a16:creationId xmlns:a16="http://schemas.microsoft.com/office/drawing/2014/main" id="{59671EA9-1842-D3AF-2517-2333E2113115}"/>
+              </a:ext>
+            </a:extLst>
+          </p:cNvPr>
+          <p:cNvSpPr>
+            <a:spLocks noGrp="1"/>
+          </p:cNvSpPr>
+          <p:nvPr>
+            <p:ph idx="1"/>
+          </p:nvPr>
+        </p:nvSpPr>
+        <p:spPr>
+          <a:xfrm>
+            <a:off x="3491049" y="850052"/>
+            <a:ext cx="4792967" cy="5326911"/>
+          </a:xfrm>
+        </p:spPr>
+        <p:txBody>
+          <a:bodyPr>
+            <a:normAutofit/>
+          </a:bodyPr>
+          <a:lstStyle/>
+          <a:p>
+            <a:pPr marL="0" indent="0">
+              <a:lnSpc>
+                <a:spcPct val="90000"/>
+              </a:lnSpc>
+              <a:buNone/>
+            </a:pPr>
+            <a:br>
+              <a:rPr lang="en-GB" sz="1200"/>
+            </a:br>
+            <a:br>
+              <a:rPr lang="en-GB" sz="1200"/>
+            </a:br>
+            <a:r>
+              <a:rPr lang="en-GB" sz="1200"/>
+              <a:t>my game uses post processing effects to improve the design and exaggerate the rage style gameplay. Effects that I used were bloom, chromatic aberration, vignette, film grain, and lens distortion. The strongest effect is the lens distortion because it visually warps the screen to the beat of the music and kinda makes the game look retro.</a:t>
+            </a:r>
+            <a:br>
+              <a:rPr lang="en-GB" sz="1200"/>
+            </a:br>
+            <a:br>
+              <a:rPr lang="en-GB" sz="1200"/>
+            </a:br>
+            <a:r>
+              <a:rPr lang="en-GB" sz="1200"/>
+              <a:t>This system is connected to the bass visualiser, meaning effects become stronger during louder parts of songs.</a:t>
+            </a:r>
+            <a:br>
+              <a:rPr lang="en-GB" sz="1200"/>
+            </a:br>
+            <a:br>
+              <a:rPr lang="en-GB" sz="1200"/>
+            </a:br>
+            <a:r>
+              <a:rPr lang="en-GB" sz="1200"/>
+              <a:t>Example code:</a:t>
+            </a:r>
+          </a:p>
+          <a:p>
+            <a:pPr marL="0" indent="0">
+              <a:lnSpc>
+                <a:spcPct val="90000"/>
+              </a:lnSpc>
+              <a:buNone/>
+            </a:pPr>
+            <a:r>
+              <a:rPr lang="en-GB" sz="1200"/>
+              <a:t>lensDistortion.intensity.value = -currentIntensity; </a:t>
+            </a:r>
+          </a:p>
+          <a:p>
+            <a:pPr marL="0" indent="0">
+              <a:lnSpc>
+                <a:spcPct val="90000"/>
+              </a:lnSpc>
+              <a:buNone/>
+            </a:pPr>
+            <a:endParaRPr lang="en-GB" sz="1200"/>
+          </a:p>
+          <a:p>
+            <a:pPr marL="0" indent="0">
+              <a:lnSpc>
+                <a:spcPct val="90000"/>
+              </a:lnSpc>
+              <a:buNone/>
+            </a:pPr>
+            <a:r>
+              <a:rPr lang="en-GB" sz="1200"/>
+              <a:t>Negative intensity values pull the screen inward which creates the warped effect seen during gameplay.</a:t>
+            </a:r>
+            <a:br>
+              <a:rPr lang="en-GB" sz="1200"/>
+            </a:br>
+            <a:br>
+              <a:rPr lang="en-GB" sz="1200"/>
+            </a:br>
+            <a:br>
+              <a:rPr lang="en-GB" sz="1200"/>
+            </a:br>
+            <a:r>
+              <a:rPr lang="en-GB" sz="1200"/>
+              <a:t>Pause Menu and UI Systems</a:t>
+            </a:r>
+            <a:br>
+              <a:rPr lang="en-GB" sz="1200"/>
+            </a:br>
+            <a:br>
+              <a:rPr lang="en-GB" sz="1200"/>
+            </a:br>
+            <a:r>
+              <a:rPr lang="en-GB" sz="1200"/>
+              <a:t>The pause menu was made to also allow players to pause gameplay and adjust settings such as audio and visual effects. The system works by changing Unity’s timescale.</a:t>
+            </a:r>
+          </a:p>
+          <a:p>
+            <a:pPr marL="0" indent="0">
+              <a:lnSpc>
+                <a:spcPct val="90000"/>
+              </a:lnSpc>
+              <a:buNone/>
+            </a:pPr>
+            <a:endParaRPr lang="en-GB" sz="1200"/>
+          </a:p>
+          <a:p>
+            <a:pPr marL="0" indent="0">
+              <a:lnSpc>
+                <a:spcPct val="90000"/>
+              </a:lnSpc>
+              <a:buNone/>
+            </a:pPr>
+            <a:r>
+              <a:rPr lang="en-GB" sz="1200"/>
+              <a:t>Time.timeScale = 0f; When paused, gameplay systems stop updating while the UI remains active. Resuming sets the timescale back to normal. Time.timeScale = 1f; I also added settings toggles for post processing effects such as bloom and lens distortion. These toggles directly enable or disable features from the bass visualiser script for players who don’t enjoy these effects. </a:t>
+            </a:r>
+            <a:endParaRPr lang="en-US" sz="1200"/>
+          </a:p>
+        </p:txBody>
+      </p:sp>
+    </p:spTree>
+    <p:extLst>
+      <p:ext uri="{BB962C8B-B14F-4D97-AF65-F5344CB8AC3E}">
+        <p14:creationId xmlns:p14="http://schemas.microsoft.com/office/powerpoint/2010/main" val="126853333"/>
+      </p:ext>
+    </p:extLst>
+  </p:cSld>
+  <p:clrMapOvr>
+    <a:masterClrMapping/>
+  </p:clrMapOvr>
+</p:sld>
+</file>
+
+<file path=ppt/slides/slide11.xml><?xml version="1.0" encoding="utf-8"?>
+<p:sld xmlns:a="http://schemas.openxmlformats.org/drawingml/2006/main" xmlns:r="http://schemas.openxmlformats.org/officeDocument/2006/relationships" xmlns:p="http://schemas.openxmlformats.org/presentationml/2006/main">
+  <p:cSld>
+    <p:bg>
+      <p:bgPr>
+        <a:solidFill>
+          <a:schemeClr val="bg1"/>
+        </a:solidFill>
+        <a:effectLst/>
+      </p:bgPr>
+    </p:bg>
+    <p:spTree>
+      <p:nvGrpSpPr>
+        <p:cNvPr id="1" name="">
+          <a:extLst>
+            <a:ext uri="{FF2B5EF4-FFF2-40B4-BE49-F238E27FC236}">
+              <a16:creationId xmlns:a16="http://schemas.microsoft.com/office/drawing/2014/main" id="{C6E15C37-56E4-834D-50C8-C6BE70BE8DF2}"/>
+            </a:ext>
+          </a:extLst>
+        </p:cNvPr>
+        <p:cNvGrpSpPr/>
+        <p:nvPr/>
+      </p:nvGrpSpPr>
+      <p:grpSpPr>
+        <a:xfrm>
+          <a:off x="0" y="0"/>
+          <a:ext cx="0" cy="0"/>
+          <a:chOff x="0" y="0"/>
+          <a:chExt cx="0" cy="0"/>
+        </a:xfrm>
+      </p:grpSpPr>
+      <p:sp>
+        <p:nvSpPr>
+          <p:cNvPr id="2" name="Title 1">
+            <a:extLst>
+              <a:ext uri="{FF2B5EF4-FFF2-40B4-BE49-F238E27FC236}">
+                <a16:creationId xmlns:a16="http://schemas.microsoft.com/office/drawing/2014/main" id="{A0F7F97A-8B20-6775-6D41-52D3D6BA8716}"/>
+              </a:ext>
+            </a:extLst>
+          </p:cNvPr>
+          <p:cNvSpPr>
+            <a:spLocks noGrp="1"/>
+          </p:cNvSpPr>
+          <p:nvPr>
+            <p:ph type="title"/>
+          </p:nvPr>
+        </p:nvSpPr>
+        <p:spPr>
+          <a:xfrm>
+            <a:off x="360759" y="3752849"/>
+            <a:ext cx="2468166" cy="2452687"/>
+          </a:xfrm>
+        </p:spPr>
+        <p:txBody>
+          <a:bodyPr anchor="ctr">
+            <a:normAutofit/>
+          </a:bodyPr>
+          <a:lstStyle/>
+          <a:p>
+            <a:r>
+              <a:rPr lang="en-GB" sz="3100"/>
+              <a:t>Testing and feedback</a:t>
+            </a:r>
+          </a:p>
+        </p:txBody>
+      </p:sp>
+      <p:pic>
+        <p:nvPicPr>
+          <p:cNvPr id="5" name="Picture 4">
+            <a:extLst>
+              <a:ext uri="{FF2B5EF4-FFF2-40B4-BE49-F238E27FC236}">
+                <a16:creationId xmlns:a16="http://schemas.microsoft.com/office/drawing/2014/main" id="{275E6079-4753-CC66-1AD7-8DB7B6D13DA3}"/>
+              </a:ext>
+            </a:extLst>
+          </p:cNvPr>
+          <p:cNvPicPr>
+            <a:picLocks noChangeAspect="1"/>
+          </p:cNvPicPr>
+          <p:nvPr/>
+        </p:nvPicPr>
+        <p:blipFill>
+          <a:blip r:embed="rId2"/>
+          <a:srcRect t="4627" b="10365"/>
+          <a:stretch>
+            <a:fillRect/>
+          </a:stretch>
+        </p:blipFill>
+        <p:spPr>
+          <a:xfrm>
+            <a:off x="0" y="-310896"/>
+            <a:ext cx="9143980" cy="4469565"/>
+          </a:xfrm>
+          <a:custGeom>
+            <a:avLst/>
+            <a:gdLst/>
+            <a:ahLst/>
+            <a:cxnLst/>
+            <a:rect l="l" t="t" r="r" b="b"/>
+            <a:pathLst>
+              <a:path w="12192000" h="3692092">
+                <a:moveTo>
+                  <a:pt x="0" y="0"/>
+                </a:moveTo>
+                <a:lnTo>
+                  <a:pt x="12192000" y="0"/>
+                </a:lnTo>
+                <a:lnTo>
+                  <a:pt x="12192000" y="3504824"/>
+                </a:lnTo>
+                <a:lnTo>
+                  <a:pt x="12024691" y="3517794"/>
+                </a:lnTo>
+                <a:cubicBezTo>
+                  <a:pt x="8077523" y="3783195"/>
+                  <a:pt x="4094678" y="3026959"/>
+                  <a:pt x="160485" y="3663863"/>
+                </a:cubicBezTo>
+                <a:lnTo>
+                  <a:pt x="0" y="3692092"/>
+                </a:lnTo>
+                <a:close/>
+              </a:path>
+            </a:pathLst>
+          </a:custGeom>
+        </p:spPr>
+      </p:pic>
+      <p:sp>
+        <p:nvSpPr>
+          <p:cNvPr id="3" name="Content Placeholder 2">
+            <a:extLst>
+              <a:ext uri="{FF2B5EF4-FFF2-40B4-BE49-F238E27FC236}">
+                <a16:creationId xmlns:a16="http://schemas.microsoft.com/office/drawing/2014/main" id="{B90516C5-72F9-D16B-CE09-AF62B19A8F1A}"/>
+              </a:ext>
+            </a:extLst>
+          </p:cNvPr>
+          <p:cNvSpPr>
+            <a:spLocks noGrp="1"/>
+          </p:cNvSpPr>
+          <p:nvPr>
+            <p:ph idx="1"/>
+          </p:nvPr>
+        </p:nvSpPr>
+        <p:spPr>
+          <a:xfrm>
+            <a:off x="3167986" y="3752850"/>
+            <a:ext cx="5614060" cy="2452687"/>
+          </a:xfrm>
+        </p:spPr>
+        <p:txBody>
+          <a:bodyPr anchor="ctr">
+            <a:normAutofit/>
+          </a:bodyPr>
+          <a:lstStyle/>
+          <a:p>
+            <a:pPr marL="0" indent="0">
+              <a:lnSpc>
+                <a:spcPct val="90000"/>
+              </a:lnSpc>
+              <a:buNone/>
+            </a:pPr>
+            <a:br>
+              <a:rPr lang="en-GB" sz="1200" dirty="0"/>
+            </a:br>
+            <a:br>
+              <a:rPr lang="en-GB" sz="1200" dirty="0"/>
+            </a:br>
+            <a:r>
+              <a:rPr lang="en-GB" sz="1200" dirty="0"/>
+              <a:t>Player feedback played an important part during the development. Play testing showed that while players enjoyed the challenge, some mechanics were unclear at first which led to changes such as adding tutorial indicators and adjusting jump timing.</a:t>
+            </a:r>
+            <a:br>
+              <a:rPr lang="en-GB" sz="1200" dirty="0"/>
+            </a:br>
+            <a:br>
+              <a:rPr lang="en-GB" sz="1200" dirty="0"/>
+            </a:br>
+            <a:r>
+              <a:rPr lang="en-GB" sz="1200" dirty="0"/>
+              <a:t>The game achieved its intended goal as several testers became visibly frustrated whilst still trying to finish the levels, which matches the design goals of a rage platformer.</a:t>
+            </a:r>
+          </a:p>
+          <a:p>
+            <a:pPr marL="0" indent="0">
+              <a:lnSpc>
+                <a:spcPct val="90000"/>
+              </a:lnSpc>
+              <a:buNone/>
+            </a:pPr>
+            <a:endParaRPr lang="en-GB" sz="1200" dirty="0"/>
+          </a:p>
+          <a:p>
+            <a:pPr marL="0" indent="0">
+              <a:lnSpc>
+                <a:spcPct val="90000"/>
+              </a:lnSpc>
+              <a:buNone/>
+            </a:pPr>
+            <a:r>
+              <a:rPr lang="en-GB" sz="1200" dirty="0"/>
+              <a:t>Some testers mentioned the difficulty scaling Is crazy but this was intended and I will be keeping this as is.</a:t>
+            </a:r>
+            <a:endParaRPr lang="en-US" sz="1200" dirty="0"/>
+          </a:p>
+        </p:txBody>
+      </p:sp>
+      <p:cxnSp>
+        <p:nvCxnSpPr>
+          <p:cNvPr id="7" name="Straight Arrow Connector 6">
+            <a:extLst>
+              <a:ext uri="{FF2B5EF4-FFF2-40B4-BE49-F238E27FC236}">
+                <a16:creationId xmlns:a16="http://schemas.microsoft.com/office/drawing/2014/main" id="{313B2932-B946-E750-7181-C3CF69991D5B}"/>
+              </a:ext>
+            </a:extLst>
+          </p:cNvPr>
+          <p:cNvCxnSpPr/>
+          <p:nvPr/>
+        </p:nvCxnSpPr>
+        <p:spPr>
+          <a:xfrm>
+            <a:off x="1051560" y="73152"/>
+            <a:ext cx="722376" cy="1088136"/>
+          </a:xfrm>
+          <a:prstGeom prst="straightConnector1">
+            <a:avLst/>
+          </a:prstGeom>
+          <a:ln>
+            <a:tailEnd type="triangle"/>
+          </a:ln>
+        </p:spPr>
+        <p:style>
+          <a:lnRef idx="2">
+            <a:schemeClr val="accent1"/>
+          </a:lnRef>
+          <a:fillRef idx="0">
+            <a:schemeClr val="accent1"/>
+          </a:fillRef>
+          <a:effectRef idx="1">
+            <a:schemeClr val="accent1"/>
+          </a:effectRef>
+          <a:fontRef idx="minor">
+            <a:schemeClr val="tx1"/>
+          </a:fontRef>
+        </p:style>
+      </p:cxnSp>
+      <p:sp>
+        <p:nvSpPr>
+          <p:cNvPr id="8" name="TextBox 7">
+            <a:extLst>
+              <a:ext uri="{FF2B5EF4-FFF2-40B4-BE49-F238E27FC236}">
+                <a16:creationId xmlns:a16="http://schemas.microsoft.com/office/drawing/2014/main" id="{C968DED5-B2D6-C85D-B7B3-1FBDD5BAFA2A}"/>
+              </a:ext>
+            </a:extLst>
+          </p:cNvPr>
+          <p:cNvSpPr txBox="1"/>
+          <p:nvPr/>
+        </p:nvSpPr>
+        <p:spPr>
+          <a:xfrm>
+            <a:off x="1051560" y="1113782"/>
+            <a:ext cx="1559722" cy="369332"/>
+          </a:xfrm>
+          <a:prstGeom prst="rect">
+            <a:avLst/>
+          </a:prstGeom>
+          <a:noFill/>
+        </p:spPr>
+        <p:txBody>
+          <a:bodyPr wrap="none" rtlCol="0">
+            <a:spAutoFit/>
+          </a:bodyPr>
+          <a:lstStyle/>
+          <a:p>
+            <a:r>
+              <a:rPr lang="en-GB" dirty="0">
+                <a:solidFill>
+                  <a:schemeClr val="bg1"/>
+                </a:solidFill>
+              </a:rPr>
+              <a:t>Death Counter</a:t>
+            </a:r>
+          </a:p>
+        </p:txBody>
+      </p:sp>
+      <p:cxnSp>
+        <p:nvCxnSpPr>
+          <p:cNvPr id="12" name="Straight Arrow Connector 11">
+            <a:extLst>
+              <a:ext uri="{FF2B5EF4-FFF2-40B4-BE49-F238E27FC236}">
+                <a16:creationId xmlns:a16="http://schemas.microsoft.com/office/drawing/2014/main" id="{9D932FCD-38E5-5666-A30F-4403853D85AC}"/>
+              </a:ext>
+            </a:extLst>
+          </p:cNvPr>
+          <p:cNvCxnSpPr/>
+          <p:nvPr/>
+        </p:nvCxnSpPr>
+        <p:spPr>
+          <a:xfrm flipH="1">
+            <a:off x="7251192" y="1627632"/>
+            <a:ext cx="128016" cy="841248"/>
+          </a:xfrm>
+          <a:prstGeom prst="straightConnector1">
+            <a:avLst/>
+          </a:prstGeom>
+          <a:ln>
+            <a:tailEnd type="triangle"/>
+          </a:ln>
+        </p:spPr>
+        <p:style>
+          <a:lnRef idx="2">
+            <a:schemeClr val="accent1"/>
+          </a:lnRef>
+          <a:fillRef idx="0">
+            <a:schemeClr val="accent1"/>
+          </a:fillRef>
+          <a:effectRef idx="1">
+            <a:schemeClr val="accent1"/>
+          </a:effectRef>
+          <a:fontRef idx="minor">
+            <a:schemeClr val="tx1"/>
+          </a:fontRef>
+        </p:style>
+      </p:cxnSp>
+      <p:sp>
+        <p:nvSpPr>
+          <p:cNvPr id="13" name="TextBox 12">
+            <a:extLst>
+              <a:ext uri="{FF2B5EF4-FFF2-40B4-BE49-F238E27FC236}">
+                <a16:creationId xmlns:a16="http://schemas.microsoft.com/office/drawing/2014/main" id="{B0F76E24-AF33-A686-D5B1-EE8A7769C2C2}"/>
+              </a:ext>
+            </a:extLst>
+          </p:cNvPr>
+          <p:cNvSpPr txBox="1"/>
+          <p:nvPr/>
+        </p:nvSpPr>
+        <p:spPr>
+          <a:xfrm>
+            <a:off x="6940947" y="1258300"/>
+            <a:ext cx="876522" cy="369332"/>
+          </a:xfrm>
+          <a:prstGeom prst="rect">
+            <a:avLst/>
+          </a:prstGeom>
+          <a:noFill/>
+        </p:spPr>
+        <p:txBody>
+          <a:bodyPr wrap="none" rtlCol="0">
+            <a:spAutoFit/>
+          </a:bodyPr>
+          <a:lstStyle/>
+          <a:p>
+            <a:r>
+              <a:rPr lang="en-GB" dirty="0">
+                <a:solidFill>
+                  <a:schemeClr val="bg1"/>
+                </a:solidFill>
+              </a:rPr>
+              <a:t>tutorial</a:t>
+            </a:r>
+          </a:p>
+        </p:txBody>
+      </p:sp>
+      <p:cxnSp>
+        <p:nvCxnSpPr>
+          <p:cNvPr id="15" name="Straight Arrow Connector 14">
+            <a:extLst>
+              <a:ext uri="{FF2B5EF4-FFF2-40B4-BE49-F238E27FC236}">
+                <a16:creationId xmlns:a16="http://schemas.microsoft.com/office/drawing/2014/main" id="{03A83570-B267-3F54-BBFF-8E2D20E518A7}"/>
+              </a:ext>
+            </a:extLst>
+          </p:cNvPr>
+          <p:cNvCxnSpPr/>
+          <p:nvPr/>
+        </p:nvCxnSpPr>
+        <p:spPr>
+          <a:xfrm flipH="1">
+            <a:off x="5010912" y="1700784"/>
+            <a:ext cx="457200" cy="502920"/>
+          </a:xfrm>
+          <a:prstGeom prst="straightConnector1">
+            <a:avLst/>
+          </a:prstGeom>
+          <a:ln>
+            <a:tailEnd type="triangle"/>
+          </a:ln>
+        </p:spPr>
+        <p:style>
+          <a:lnRef idx="2">
+            <a:schemeClr val="accent1"/>
+          </a:lnRef>
+          <a:fillRef idx="0">
+            <a:schemeClr val="accent1"/>
+          </a:fillRef>
+          <a:effectRef idx="1">
+            <a:schemeClr val="accent1"/>
+          </a:effectRef>
+          <a:fontRef idx="minor">
+            <a:schemeClr val="tx1"/>
+          </a:fontRef>
+        </p:style>
+      </p:cxnSp>
+      <p:cxnSp>
+        <p:nvCxnSpPr>
+          <p:cNvPr id="19" name="Straight Arrow Connector 18">
+            <a:extLst>
+              <a:ext uri="{FF2B5EF4-FFF2-40B4-BE49-F238E27FC236}">
+                <a16:creationId xmlns:a16="http://schemas.microsoft.com/office/drawing/2014/main" id="{7FCDD70C-989D-6FC9-F34C-F139A1B0CEC8}"/>
+              </a:ext>
+            </a:extLst>
+          </p:cNvPr>
+          <p:cNvCxnSpPr/>
+          <p:nvPr/>
+        </p:nvCxnSpPr>
+        <p:spPr>
+          <a:xfrm>
+            <a:off x="6099048" y="1113782"/>
+            <a:ext cx="749808" cy="1967746"/>
+          </a:xfrm>
+          <a:prstGeom prst="straightConnector1">
+            <a:avLst/>
+          </a:prstGeom>
+          <a:ln>
+            <a:tailEnd type="triangle"/>
+          </a:ln>
+        </p:spPr>
+        <p:style>
+          <a:lnRef idx="2">
+            <a:schemeClr val="accent1"/>
+          </a:lnRef>
+          <a:fillRef idx="0">
+            <a:schemeClr val="accent1"/>
+          </a:fillRef>
+          <a:effectRef idx="1">
+            <a:schemeClr val="accent1"/>
+          </a:effectRef>
+          <a:fontRef idx="minor">
+            <a:schemeClr val="tx1"/>
+          </a:fontRef>
+        </p:style>
+      </p:cxnSp>
+      <p:sp>
+        <p:nvSpPr>
+          <p:cNvPr id="20" name="TextBox 19">
+            <a:extLst>
+              <a:ext uri="{FF2B5EF4-FFF2-40B4-BE49-F238E27FC236}">
+                <a16:creationId xmlns:a16="http://schemas.microsoft.com/office/drawing/2014/main" id="{FF8AF0CC-7496-86BC-6947-D29BB62A02DD}"/>
+              </a:ext>
+            </a:extLst>
+          </p:cNvPr>
+          <p:cNvSpPr txBox="1"/>
+          <p:nvPr/>
+        </p:nvSpPr>
+        <p:spPr>
+          <a:xfrm>
+            <a:off x="5132835" y="1351645"/>
+            <a:ext cx="762645" cy="369332"/>
+          </a:xfrm>
+          <a:prstGeom prst="rect">
+            <a:avLst/>
+          </a:prstGeom>
+          <a:noFill/>
+        </p:spPr>
+        <p:txBody>
+          <a:bodyPr wrap="none" rtlCol="0">
+            <a:spAutoFit/>
+          </a:bodyPr>
+          <a:lstStyle/>
+          <a:p>
+            <a:r>
+              <a:rPr lang="en-GB" dirty="0">
+                <a:solidFill>
+                  <a:schemeClr val="bg1"/>
+                </a:solidFill>
+              </a:rPr>
+              <a:t>player</a:t>
+            </a:r>
+          </a:p>
+        </p:txBody>
+      </p:sp>
+      <p:sp>
+        <p:nvSpPr>
+          <p:cNvPr id="21" name="TextBox 20">
+            <a:extLst>
+              <a:ext uri="{FF2B5EF4-FFF2-40B4-BE49-F238E27FC236}">
+                <a16:creationId xmlns:a16="http://schemas.microsoft.com/office/drawing/2014/main" id="{427B5701-B514-E4DA-E1DC-3F62ED3AC45C}"/>
+              </a:ext>
+            </a:extLst>
+          </p:cNvPr>
+          <p:cNvSpPr txBox="1"/>
+          <p:nvPr/>
+        </p:nvSpPr>
+        <p:spPr>
+          <a:xfrm>
+            <a:off x="5730888" y="778097"/>
+            <a:ext cx="569451" cy="369332"/>
+          </a:xfrm>
+          <a:prstGeom prst="rect">
+            <a:avLst/>
+          </a:prstGeom>
+          <a:noFill/>
+        </p:spPr>
+        <p:txBody>
+          <a:bodyPr wrap="none" rtlCol="0">
+            <a:spAutoFit/>
+          </a:bodyPr>
+          <a:lstStyle/>
+          <a:p>
+            <a:r>
+              <a:rPr lang="en-GB" dirty="0">
+                <a:solidFill>
+                  <a:schemeClr val="bg1"/>
+                </a:solidFill>
+              </a:rPr>
+              <a:t>trap</a:t>
+            </a:r>
+          </a:p>
+        </p:txBody>
+      </p:sp>
+    </p:spTree>
+    <p:extLst>
+      <p:ext uri="{BB962C8B-B14F-4D97-AF65-F5344CB8AC3E}">
+        <p14:creationId xmlns:p14="http://schemas.microsoft.com/office/powerpoint/2010/main" val="3333566731"/>
+      </p:ext>
+    </p:extLst>
+  </p:cSld>
+  <p:clrMapOvr>
+    <a:masterClrMapping/>
+  </p:clrMapOvr>
+</p:sld>
+</file>
+
 <file path=ppt/slides/slide2.xml><?xml version="1.0" encoding="utf-8"?>
 <p:sld xmlns:a="http://schemas.openxmlformats.org/drawingml/2006/main" xmlns:r="http://schemas.openxmlformats.org/officeDocument/2006/relationships" xmlns:p="http://schemas.openxmlformats.org/presentationml/2006/main">
   <p:cSld>
@@ -8201,8 +9157,32 @@
               <a:buNone/>
             </a:pPr>
             <a:r>
-              <a:rPr lang="en-US" sz="1600"/>
-              <a:t>Several issues occurred during development. UI did not work due to missing EventSystems. Cursor blocked buttons as I used a cursor image to have post processing affect the cursor so clicks did not register due to raycast settings. Settings did not save between scenes, which was fixed using PlayerPrefs or a persistent manager. I also had issues with level design as I was stuck on what to make that could be challenging for players, so I went back on geometry dash and used a few levels as inspiration form the new platformer mode. Each problem was tested and solved step by step.</a:t>
+              <a:rPr lang="en-US" sz="1600" dirty="0"/>
+              <a:t>Several issues occurred during development. UI did not work due to missing </a:t>
+            </a:r>
+            <a:r>
+              <a:rPr lang="en-US" sz="1600" dirty="0" err="1"/>
+              <a:t>EventSystems</a:t>
+            </a:r>
+            <a:r>
+              <a:rPr lang="en-US" sz="1600" dirty="0"/>
+              <a:t>. Cursor blocked buttons as I used a cursor image to have post processing affect the cursor so clicks did not register due to </a:t>
+            </a:r>
+            <a:r>
+              <a:rPr lang="en-US" sz="1600" dirty="0" err="1"/>
+              <a:t>raycast</a:t>
+            </a:r>
+            <a:r>
+              <a:rPr lang="en-US" sz="1600" dirty="0"/>
+              <a:t> settings. Settings did not save between scenes, which was fixed using </a:t>
+            </a:r>
+            <a:r>
+              <a:rPr lang="en-US" sz="1600" dirty="0" err="1"/>
+              <a:t>PlayerPrefs</a:t>
+            </a:r>
+            <a:r>
+              <a:rPr lang="en-US" sz="1600" dirty="0"/>
+              <a:t> or a persistent manager. I also had issues with level design as I was stuck on what to make that could be challenging for players, so I went back on geometry dash and used a few levels as inspiration form the new platformer mode. Each problem was tested and solved step by step.</a:t>
             </a:r>
           </a:p>
         </p:txBody>
@@ -8293,6 +9273,640 @@
         </p:txBody>
       </p:sp>
     </p:spTree>
+  </p:cSld>
+  <p:clrMapOvr>
+    <a:masterClrMapping/>
+  </p:clrMapOvr>
+</p:sld>
+</file>
+
+<file path=ppt/slides/slide9.xml><?xml version="1.0" encoding="utf-8"?>
+<p:sld xmlns:a="http://schemas.openxmlformats.org/drawingml/2006/main" xmlns:r="http://schemas.openxmlformats.org/officeDocument/2006/relationships" xmlns:p="http://schemas.openxmlformats.org/presentationml/2006/main">
+  <p:cSld>
+    <p:bg>
+      <p:bgPr>
+        <a:solidFill>
+          <a:schemeClr val="bg1"/>
+        </a:solidFill>
+        <a:effectLst/>
+      </p:bgPr>
+    </p:bg>
+    <p:spTree>
+      <p:nvGrpSpPr>
+        <p:cNvPr id="1" name="">
+          <a:extLst>
+            <a:ext uri="{FF2B5EF4-FFF2-40B4-BE49-F238E27FC236}">
+              <a16:creationId xmlns:a16="http://schemas.microsoft.com/office/drawing/2014/main" id="{51848EA1-4116-CA47-D86F-7CC3295F46D3}"/>
+            </a:ext>
+          </a:extLst>
+        </p:cNvPr>
+        <p:cNvGrpSpPr/>
+        <p:nvPr/>
+      </p:nvGrpSpPr>
+      <p:grpSpPr>
+        <a:xfrm>
+          <a:off x="0" y="0"/>
+          <a:ext cx="0" cy="0"/>
+          <a:chOff x="0" y="0"/>
+          <a:chExt cx="0" cy="0"/>
+        </a:xfrm>
+      </p:grpSpPr>
+      <p:sp>
+        <p:nvSpPr>
+          <p:cNvPr id="2" name="Title 1">
+            <a:extLst>
+              <a:ext uri="{FF2B5EF4-FFF2-40B4-BE49-F238E27FC236}">
+                <a16:creationId xmlns:a16="http://schemas.microsoft.com/office/drawing/2014/main" id="{55200CC8-2796-7C93-70C4-EDC8D24DFBE7}"/>
+              </a:ext>
+            </a:extLst>
+          </p:cNvPr>
+          <p:cNvSpPr>
+            <a:spLocks noGrp="1"/>
+          </p:cNvSpPr>
+          <p:nvPr>
+            <p:ph type="title"/>
+          </p:nvPr>
+        </p:nvSpPr>
+        <p:spPr>
+          <a:xfrm>
+            <a:off x="4371562" y="857038"/>
+            <a:ext cx="4198652" cy="1402470"/>
+          </a:xfrm>
+        </p:spPr>
+        <p:txBody>
+          <a:bodyPr anchor="t">
+            <a:normAutofit/>
+          </a:bodyPr>
+          <a:lstStyle/>
+          <a:p>
+            <a:r>
+              <a:rPr lang="en-GB" sz="2800" dirty="0"/>
+              <a:t>Bass Visualiser </a:t>
+            </a:r>
+          </a:p>
+        </p:txBody>
+      </p:sp>
+      <p:pic>
+        <p:nvPicPr>
+          <p:cNvPr id="7" name="Picture 6">
+            <a:extLst>
+              <a:ext uri="{FF2B5EF4-FFF2-40B4-BE49-F238E27FC236}">
+                <a16:creationId xmlns:a16="http://schemas.microsoft.com/office/drawing/2014/main" id="{68A96E85-5573-8C88-8C20-69A66660C195}"/>
+              </a:ext>
+            </a:extLst>
+          </p:cNvPr>
+          <p:cNvPicPr>
+            <a:picLocks noChangeAspect="1"/>
+          </p:cNvPicPr>
+          <p:nvPr/>
+        </p:nvPicPr>
+        <p:blipFill>
+          <a:blip r:embed="rId2"/>
+          <a:stretch>
+            <a:fillRect/>
+          </a:stretch>
+        </p:blipFill>
+        <p:spPr>
+          <a:xfrm>
+            <a:off x="322623" y="1331644"/>
+            <a:ext cx="2388703" cy="5459894"/>
+          </a:xfrm>
+          <a:prstGeom prst="rect">
+            <a:avLst/>
+          </a:prstGeom>
+        </p:spPr>
+      </p:pic>
+      <p:cxnSp>
+        <p:nvCxnSpPr>
+          <p:cNvPr id="33" name="Straight Connector 32">
+            <a:extLst>
+              <a:ext uri="{FF2B5EF4-FFF2-40B4-BE49-F238E27FC236}">
+                <a16:creationId xmlns:a16="http://schemas.microsoft.com/office/drawing/2014/main" id="{1503BFE4-729B-D9D0-C17B-501E6AF1127A}"/>
+              </a:ext>
+              <a:ext uri="{C183D7F6-B498-43B3-948B-1728B52AA6E4}">
+                <adec:decorative xmlns:adec="http://schemas.microsoft.com/office/drawing/2017/decorative" val="1"/>
+              </a:ext>
+            </a:extLst>
+          </p:cNvPr>
+          <p:cNvCxnSpPr>
+            <a:cxnSpLocks noGrp="1" noRot="1" noChangeAspect="1" noMove="1" noResize="1" noEditPoints="1" noAdjustHandles="1" noChangeArrowheads="1" noChangeShapeType="1"/>
+          </p:cNvCxnSpPr>
+          <p:nvPr>
+            <p:extLst>
+              <p:ext uri="{386F3935-93C4-4BCD-93E2-E3B085C9AB24}">
+                <p16:designElem xmlns:p16="http://schemas.microsoft.com/office/powerpoint/2015/main" val="1"/>
+              </p:ext>
+            </p:extLst>
+          </p:nvPr>
+        </p:nvCxnSpPr>
+        <p:spPr>
+          <a:xfrm>
+            <a:off x="4394053" y="871146"/>
+            <a:ext cx="552704" cy="0"/>
+          </a:xfrm>
+          <a:prstGeom prst="line">
+            <a:avLst/>
+          </a:prstGeom>
+          <a:ln w="57150">
+            <a:solidFill>
+              <a:schemeClr val="accent4"/>
+            </a:solidFill>
+          </a:ln>
+        </p:spPr>
+        <p:style>
+          <a:lnRef idx="1">
+            <a:schemeClr val="accent1"/>
+          </a:lnRef>
+          <a:fillRef idx="0">
+            <a:schemeClr val="accent1"/>
+          </a:fillRef>
+          <a:effectRef idx="0">
+            <a:schemeClr val="accent1"/>
+          </a:effectRef>
+          <a:fontRef idx="minor">
+            <a:schemeClr val="tx1"/>
+          </a:fontRef>
+        </p:style>
+      </p:cxnSp>
+      <p:sp>
+        <p:nvSpPr>
+          <p:cNvPr id="3" name="Content Placeholder 2">
+            <a:extLst>
+              <a:ext uri="{FF2B5EF4-FFF2-40B4-BE49-F238E27FC236}">
+                <a16:creationId xmlns:a16="http://schemas.microsoft.com/office/drawing/2014/main" id="{E8EE8ADD-CE69-67C3-205E-6B6F0E14441A}"/>
+              </a:ext>
+            </a:extLst>
+          </p:cNvPr>
+          <p:cNvSpPr>
+            <a:spLocks noGrp="1"/>
+          </p:cNvSpPr>
+          <p:nvPr>
+            <p:ph idx="1"/>
+          </p:nvPr>
+        </p:nvSpPr>
+        <p:spPr>
+          <a:xfrm>
+            <a:off x="4670405" y="1331644"/>
+            <a:ext cx="4083287" cy="3591207"/>
+          </a:xfrm>
+        </p:spPr>
+        <p:txBody>
+          <a:bodyPr>
+            <a:noAutofit/>
+          </a:bodyPr>
+          <a:lstStyle/>
+          <a:p>
+            <a:pPr marL="0" indent="0">
+              <a:lnSpc>
+                <a:spcPct val="90000"/>
+              </a:lnSpc>
+              <a:buNone/>
+            </a:pPr>
+            <a:r>
+              <a:rPr lang="en-GB" sz="1100" dirty="0"/>
+              <a:t>One of the more complicated systems I created was the bass reactive visualiser for the levels. This system reacts to the music currently playing in the level and changes post processing effects based on the bass intensity. This helped make the game feel more dynamic and visually interesting.</a:t>
+            </a:r>
+          </a:p>
+          <a:p>
+            <a:pPr>
+              <a:lnSpc>
+                <a:spcPct val="90000"/>
+              </a:lnSpc>
+            </a:pPr>
+            <a:endParaRPr lang="en-GB" sz="1100" dirty="0"/>
+          </a:p>
+          <a:p>
+            <a:pPr marL="0" indent="0">
+              <a:lnSpc>
+                <a:spcPct val="90000"/>
+              </a:lnSpc>
+              <a:buNone/>
+            </a:pPr>
+            <a:r>
+              <a:rPr lang="en-GB" sz="1100" dirty="0"/>
+              <a:t>The system works by reading frequency data from the audio source using Unity’s </a:t>
+            </a:r>
+            <a:r>
+              <a:rPr lang="en-GB" sz="1100" dirty="0" err="1"/>
+              <a:t>GetSpectrumData</a:t>
+            </a:r>
+            <a:r>
+              <a:rPr lang="en-GB" sz="1100" dirty="0"/>
+              <a:t>() function. Lower indexes in the spectrum array are bass frequencies, so I focused mainly on those values.</a:t>
+            </a:r>
+          </a:p>
+          <a:p>
+            <a:pPr marL="0" indent="0">
+              <a:lnSpc>
+                <a:spcPct val="90000"/>
+              </a:lnSpc>
+              <a:buNone/>
+            </a:pPr>
+            <a:r>
+              <a:rPr lang="en-GB" sz="1100" dirty="0"/>
+              <a:t> </a:t>
+            </a:r>
+          </a:p>
+          <a:p>
+            <a:pPr marL="0" indent="0">
+              <a:lnSpc>
+                <a:spcPct val="90000"/>
+              </a:lnSpc>
+              <a:buNone/>
+            </a:pPr>
+            <a:endParaRPr lang="en-GB" sz="1100" dirty="0"/>
+          </a:p>
+          <a:p>
+            <a:pPr marL="0" indent="0">
+              <a:lnSpc>
+                <a:spcPct val="90000"/>
+              </a:lnSpc>
+              <a:buNone/>
+            </a:pPr>
+            <a:r>
+              <a:rPr lang="en-GB" sz="1100" dirty="0" err="1"/>
+              <a:t>music.GetSpectrumData</a:t>
+            </a:r>
+            <a:r>
+              <a:rPr lang="en-GB" sz="1100" dirty="0"/>
+              <a:t>(spectrum, 0, </a:t>
+            </a:r>
+            <a:r>
+              <a:rPr lang="en-GB" sz="1100" dirty="0" err="1"/>
+              <a:t>FFTWindow.Blackman</a:t>
+            </a:r>
+            <a:r>
+              <a:rPr lang="en-GB" sz="1100" dirty="0"/>
+              <a:t>);</a:t>
+            </a:r>
+            <a:br>
+              <a:rPr lang="en-GB" sz="1100" dirty="0"/>
+            </a:br>
+            <a:br>
+              <a:rPr lang="en-GB" sz="1100" dirty="0"/>
+            </a:br>
+            <a:r>
+              <a:rPr lang="en-GB" sz="1100" dirty="0"/>
+              <a:t>float bass = 0f;</a:t>
+            </a:r>
+            <a:br>
+              <a:rPr lang="en-GB" sz="1100" dirty="0"/>
+            </a:br>
+            <a:br>
+              <a:rPr lang="en-GB" sz="1100" dirty="0"/>
+            </a:br>
+            <a:r>
+              <a:rPr lang="en-GB" sz="1100" dirty="0"/>
+              <a:t>for (int </a:t>
+            </a:r>
+            <a:r>
+              <a:rPr lang="en-GB" sz="1100" dirty="0" err="1"/>
+              <a:t>i</a:t>
+            </a:r>
+            <a:r>
+              <a:rPr lang="en-GB" sz="1100" dirty="0"/>
+              <a:t> = 0; </a:t>
+            </a:r>
+            <a:r>
+              <a:rPr lang="en-GB" sz="1100" dirty="0" err="1"/>
+              <a:t>i</a:t>
+            </a:r>
+            <a:r>
+              <a:rPr lang="en-GB" sz="1100" dirty="0"/>
+              <a:t> &lt; 3; </a:t>
+            </a:r>
+            <a:r>
+              <a:rPr lang="en-GB" sz="1100" dirty="0" err="1"/>
+              <a:t>i</a:t>
+            </a:r>
+            <a:r>
+              <a:rPr lang="en-GB" sz="1100" dirty="0"/>
+              <a:t>++)</a:t>
+            </a:r>
+            <a:br>
+              <a:rPr lang="en-GB" sz="1100" dirty="0"/>
+            </a:br>
+            <a:r>
+              <a:rPr lang="en-GB" sz="1100" dirty="0"/>
+              <a:t>{</a:t>
+            </a:r>
+            <a:br>
+              <a:rPr lang="en-GB" sz="1100" dirty="0"/>
+            </a:br>
+            <a:r>
+              <a:rPr lang="en-GB" sz="1100" dirty="0"/>
+              <a:t>   bass += spectrum[</a:t>
+            </a:r>
+            <a:r>
+              <a:rPr lang="en-GB" sz="1100" dirty="0" err="1"/>
+              <a:t>i</a:t>
+            </a:r>
+            <a:r>
+              <a:rPr lang="en-GB" sz="1100" dirty="0"/>
+              <a:t>];</a:t>
+            </a:r>
+            <a:br>
+              <a:rPr lang="en-GB" sz="1100" dirty="0"/>
+            </a:br>
+            <a:r>
+              <a:rPr lang="en-GB" sz="1100" dirty="0"/>
+              <a:t>}</a:t>
+            </a:r>
+          </a:p>
+          <a:p>
+            <a:pPr marL="0" indent="0">
+              <a:lnSpc>
+                <a:spcPct val="90000"/>
+              </a:lnSpc>
+              <a:buNone/>
+            </a:pPr>
+            <a:endParaRPr lang="en-GB" sz="1100" dirty="0"/>
+          </a:p>
+          <a:p>
+            <a:pPr marL="0" indent="0">
+              <a:lnSpc>
+                <a:spcPct val="90000"/>
+              </a:lnSpc>
+              <a:buNone/>
+            </a:pPr>
+            <a:r>
+              <a:rPr lang="en-GB" sz="1100" dirty="0"/>
+              <a:t>The bass value is then used to affect visual effects such as bloom and lens distortion, etc. I also used smoothing to stop the visuals from spamming too aggressively. </a:t>
+            </a:r>
+          </a:p>
+          <a:p>
+            <a:pPr marL="0" indent="0">
+              <a:lnSpc>
+                <a:spcPct val="90000"/>
+              </a:lnSpc>
+              <a:buNone/>
+            </a:pPr>
+            <a:endParaRPr lang="en-GB" sz="1100" dirty="0"/>
+          </a:p>
+          <a:p>
+            <a:pPr marL="0" indent="0">
+              <a:lnSpc>
+                <a:spcPct val="90000"/>
+              </a:lnSpc>
+              <a:buNone/>
+            </a:pPr>
+            <a:r>
+              <a:rPr lang="en-GB" sz="1100" dirty="0" err="1"/>
+              <a:t>currentIntensity</a:t>
+            </a:r>
+            <a:r>
+              <a:rPr lang="en-GB" sz="1100" dirty="0"/>
+              <a:t> = </a:t>
+            </a:r>
+            <a:r>
+              <a:rPr lang="en-GB" sz="1100" dirty="0" err="1"/>
+              <a:t>Mathf.Lerp</a:t>
+            </a:r>
+            <a:r>
+              <a:rPr lang="en-GB" sz="1100" dirty="0"/>
+              <a:t>(</a:t>
+            </a:r>
+            <a:br>
+              <a:rPr lang="en-GB" sz="1100" dirty="0"/>
+            </a:br>
+            <a:r>
+              <a:rPr lang="en-GB" sz="1100" dirty="0"/>
+              <a:t>   </a:t>
+            </a:r>
+            <a:r>
+              <a:rPr lang="en-GB" sz="1100" dirty="0" err="1"/>
+              <a:t>currentIntensity</a:t>
+            </a:r>
+            <a:r>
+              <a:rPr lang="en-GB" sz="1100" dirty="0"/>
+              <a:t>,</a:t>
+            </a:r>
+            <a:br>
+              <a:rPr lang="en-GB" sz="1100" dirty="0"/>
+            </a:br>
+            <a:r>
+              <a:rPr lang="en-GB" sz="1100" dirty="0"/>
+              <a:t>   bass * </a:t>
+            </a:r>
+            <a:r>
+              <a:rPr lang="en-GB" sz="1100" dirty="0" err="1"/>
+              <a:t>intensityMultiplier</a:t>
+            </a:r>
+            <a:r>
+              <a:rPr lang="en-GB" sz="1100" dirty="0"/>
+              <a:t>,</a:t>
+            </a:r>
+            <a:br>
+              <a:rPr lang="en-GB" sz="1100" dirty="0"/>
+            </a:br>
+            <a:r>
+              <a:rPr lang="en-GB" sz="1100" dirty="0"/>
+              <a:t>   </a:t>
+            </a:r>
+            <a:r>
+              <a:rPr lang="en-GB" sz="1100" dirty="0" err="1"/>
+              <a:t>Time.deltaTime</a:t>
+            </a:r>
+            <a:r>
+              <a:rPr lang="en-GB" sz="1100" dirty="0"/>
+              <a:t> * </a:t>
+            </a:r>
+            <a:r>
+              <a:rPr lang="en-GB" sz="1100" dirty="0" err="1"/>
+              <a:t>smoothSpeed</a:t>
+            </a:r>
+            <a:br>
+              <a:rPr lang="en-GB" sz="1100" dirty="0"/>
+            </a:br>
+            <a:r>
+              <a:rPr lang="en-GB" sz="1100" dirty="0"/>
+              <a:t>);</a:t>
+            </a:r>
+          </a:p>
+          <a:p>
+            <a:pPr marL="0" indent="0">
+              <a:lnSpc>
+                <a:spcPct val="90000"/>
+              </a:lnSpc>
+              <a:buNone/>
+            </a:pPr>
+            <a:endParaRPr lang="en-GB" sz="1100" dirty="0"/>
+          </a:p>
+          <a:p>
+            <a:pPr marL="0" indent="0">
+              <a:lnSpc>
+                <a:spcPct val="90000"/>
+              </a:lnSpc>
+              <a:buNone/>
+            </a:pPr>
+            <a:r>
+              <a:rPr lang="en-GB" sz="1100" dirty="0"/>
+              <a:t>This created a pulsing effect synced with the music and made the levels feel more and made the game seem like geometry dash. </a:t>
+            </a:r>
+            <a:endParaRPr lang="en-US" sz="1100" dirty="0"/>
+          </a:p>
+        </p:txBody>
+      </p:sp>
+      <p:cxnSp>
+        <p:nvCxnSpPr>
+          <p:cNvPr id="10" name="Straight Arrow Connector 9">
+            <a:extLst>
+              <a:ext uri="{FF2B5EF4-FFF2-40B4-BE49-F238E27FC236}">
+                <a16:creationId xmlns:a16="http://schemas.microsoft.com/office/drawing/2014/main" id="{F500D7EE-1DF9-3D0D-0132-55FD0D8953EF}"/>
+              </a:ext>
+            </a:extLst>
+          </p:cNvPr>
+          <p:cNvCxnSpPr>
+            <a:cxnSpLocks/>
+          </p:cNvCxnSpPr>
+          <p:nvPr/>
+        </p:nvCxnSpPr>
+        <p:spPr>
+          <a:xfrm flipH="1">
+            <a:off x="1691640" y="969264"/>
+            <a:ext cx="265176" cy="493776"/>
+          </a:xfrm>
+          <a:prstGeom prst="straightConnector1">
+            <a:avLst/>
+          </a:prstGeom>
+          <a:ln>
+            <a:tailEnd type="triangle"/>
+          </a:ln>
+        </p:spPr>
+        <p:style>
+          <a:lnRef idx="2">
+            <a:schemeClr val="accent1"/>
+          </a:lnRef>
+          <a:fillRef idx="0">
+            <a:schemeClr val="accent1"/>
+          </a:fillRef>
+          <a:effectRef idx="1">
+            <a:schemeClr val="accent1"/>
+          </a:effectRef>
+          <a:fontRef idx="minor">
+            <a:schemeClr val="tx1"/>
+          </a:fontRef>
+        </p:style>
+      </p:cxnSp>
+      <p:sp>
+        <p:nvSpPr>
+          <p:cNvPr id="15" name="TextBox 14">
+            <a:extLst>
+              <a:ext uri="{FF2B5EF4-FFF2-40B4-BE49-F238E27FC236}">
+                <a16:creationId xmlns:a16="http://schemas.microsoft.com/office/drawing/2014/main" id="{945582FF-8E58-1C3C-8543-D4193A3107E5}"/>
+              </a:ext>
+            </a:extLst>
+          </p:cNvPr>
+          <p:cNvSpPr txBox="1"/>
+          <p:nvPr/>
+        </p:nvSpPr>
+        <p:spPr>
+          <a:xfrm>
+            <a:off x="918422" y="672372"/>
+            <a:ext cx="2076787" cy="369332"/>
+          </a:xfrm>
+          <a:prstGeom prst="rect">
+            <a:avLst/>
+          </a:prstGeom>
+          <a:noFill/>
+        </p:spPr>
+        <p:txBody>
+          <a:bodyPr wrap="none" rtlCol="0">
+            <a:spAutoFit/>
+          </a:bodyPr>
+          <a:lstStyle/>
+          <a:p>
+            <a:r>
+              <a:rPr lang="en-GB" dirty="0"/>
+              <a:t>My bass pulse script</a:t>
+            </a:r>
+          </a:p>
+        </p:txBody>
+      </p:sp>
+      <p:cxnSp>
+        <p:nvCxnSpPr>
+          <p:cNvPr id="29" name="Straight Arrow Connector 28">
+            <a:extLst>
+              <a:ext uri="{FF2B5EF4-FFF2-40B4-BE49-F238E27FC236}">
+                <a16:creationId xmlns:a16="http://schemas.microsoft.com/office/drawing/2014/main" id="{529C243D-2439-43EB-6AFC-718DFEFACB53}"/>
+              </a:ext>
+            </a:extLst>
+          </p:cNvPr>
+          <p:cNvCxnSpPr/>
+          <p:nvPr/>
+        </p:nvCxnSpPr>
+        <p:spPr>
+          <a:xfrm flipH="1">
+            <a:off x="1516974" y="2414016"/>
+            <a:ext cx="3219618" cy="3026664"/>
+          </a:xfrm>
+          <a:prstGeom prst="straightConnector1">
+            <a:avLst/>
+          </a:prstGeom>
+          <a:ln>
+            <a:tailEnd type="triangle"/>
+          </a:ln>
+        </p:spPr>
+        <p:style>
+          <a:lnRef idx="2">
+            <a:schemeClr val="accent1"/>
+          </a:lnRef>
+          <a:fillRef idx="0">
+            <a:schemeClr val="accent1"/>
+          </a:fillRef>
+          <a:effectRef idx="1">
+            <a:schemeClr val="accent1"/>
+          </a:effectRef>
+          <a:fontRef idx="minor">
+            <a:schemeClr val="tx1"/>
+          </a:fontRef>
+        </p:style>
+      </p:cxnSp>
+      <p:cxnSp>
+        <p:nvCxnSpPr>
+          <p:cNvPr id="31" name="Straight Arrow Connector 30">
+            <a:extLst>
+              <a:ext uri="{FF2B5EF4-FFF2-40B4-BE49-F238E27FC236}">
+                <a16:creationId xmlns:a16="http://schemas.microsoft.com/office/drawing/2014/main" id="{AC965B5E-E93F-A4C3-57DD-51F6AF62267C}"/>
+              </a:ext>
+            </a:extLst>
+          </p:cNvPr>
+          <p:cNvCxnSpPr/>
+          <p:nvPr/>
+        </p:nvCxnSpPr>
+        <p:spPr>
+          <a:xfrm flipH="1">
+            <a:off x="2711326" y="5093208"/>
+            <a:ext cx="2025266" cy="1261872"/>
+          </a:xfrm>
+          <a:prstGeom prst="straightConnector1">
+            <a:avLst/>
+          </a:prstGeom>
+          <a:ln>
+            <a:tailEnd type="triangle"/>
+          </a:ln>
+        </p:spPr>
+        <p:style>
+          <a:lnRef idx="2">
+            <a:schemeClr val="accent1"/>
+          </a:lnRef>
+          <a:fillRef idx="0">
+            <a:schemeClr val="accent1"/>
+          </a:fillRef>
+          <a:effectRef idx="1">
+            <a:schemeClr val="accent1"/>
+          </a:effectRef>
+          <a:fontRef idx="minor">
+            <a:schemeClr val="tx1"/>
+          </a:fontRef>
+        </p:style>
+      </p:cxnSp>
+    </p:spTree>
+    <p:extLst>
+      <p:ext uri="{BB962C8B-B14F-4D97-AF65-F5344CB8AC3E}">
+        <p14:creationId xmlns:p14="http://schemas.microsoft.com/office/powerpoint/2010/main" val="1581972006"/>
+      </p:ext>
+    </p:extLst>
   </p:cSld>
   <p:clrMapOvr>
     <a:masterClrMapping/>

</xml_diff>